<commit_message>
Correct activation logic: London 6-9 block counts within annual 12
The 12 annual partnership activations no longer exclude London; the
London Forum is expected to deliver a concentrated block of 6-9 within
that annual commitment. Separately sponsored activations (Breakfast,
Gala) sit above the baseline. Slide and speaker-note wording updated on
slides 2, 5 and 6; all figures and the comp-ticket rule unchanged.

Co-Authored-By: Claude Fable 5 <noreply@anthropic.com>
Claude-Session: https://claude.ai/code/session_01U9XeMw7ABaQwbqiGTutLgU
</commit_message>
<xml_diff>
--- a/presentations/zeta-partnership/zeta-emailexpert-partnership-2026.pptx
+++ b/presentations/zeta-partnership/zeta-emailexpert-partnership-2026.pptx
@@ -595,7 +595,7 @@
           <a:p>
             <a:r>
               <a:rPr lang="en-US" dirty="0"/>
-              <a:t>Left column is contractual — present it as what Zeta can rely on, never as goodwill. The 9 tickets carry the only attributed value here (£3,555 at the conservative £395 benchmark); the 4 London places come out of the 9, so nothing is valued twice. Right column is voluntary: a minimum of 12 meaningful partnership activations across the year, excluding London. Emphasise that emailexpert brings ideas proactively. No monetary value is placed on the 12 activations. The additional commitments are for the 2026/27 term and do not renew automatically — say this warmly, as a launch-year investment in making the relationship succeed.</a:t>
+              <a:t>Left column is contractual — present it as what Zeta can rely on, never as goodwill. The 9 tickets carry the only attributed value here (£3,555 at the conservative £395 benchmark); the 4 London places come out of the 9, so nothing is valued twice. Right column is voluntary: the 12 activations are the annual partnership baseline. London is expected to deliver a concentrated block of 6–9 within that baseline, while separately sponsored activations such as Breakfast or Gala increase the total opportunity set. Emphasise that emailexpert brings ideas proactively. No monetary value is placed on the 12 activations. The additional commitments are for the 2026/27 term and do not renew automatically — say this warmly, as a launch-year investment in making the relationship succeed.</a:t>
             </a:r>
             <a:endParaRPr lang="en-US" dirty="0"/>
           </a:p>
@@ -859,7 +859,7 @@
           <a:p>
             <a:r>
               <a:rPr lang="en-US" dirty="0"/>
-              <a:t>Keep the contractual Platinum package distinct from the additional London commitment. Observer passes are for guests Zeta invites — prospects, clients and partners — not staff tickets, they are not additional delegate inventory, and no value is attributed to them. The session is flexible in format but substantive in character. On the right: 6–9 facilitated London activations sit on top of the annual 12 — London does not consume the partnership commitment — and an accepted complimentary ticket alone never counts as an activation. No monetary value is placed on the 6–9 activations. The standard delegate directory (name, job title, organisation, subject to opt-out) is separate from the sponsored landing-page data flow.</a:t>
+              <a:t>Keep the contractual Platinum package distinct from the additional London commitment. Observer passes are for guests Zeta invites — prospects, clients and partners — not staff tickets, they are not additional delegate inventory, and no value is attributed to them. The session is flexible in format but substantive in character. On the right: the 6–9 facilitated London activations are a concentrated block within the annual commitment of 12 — if London delivers 9, at least 3 remain committed across the rest of the term. Separately sponsored activations, such as the Breakfast or Gala, sit above that baseline and increase the total opportunity set. An accepted complimentary ticket alone never counts as an activation, and no monetary value is placed on the 6–9 activations. The standard delegate directory (name, job title, organisation, subject to opt-out) is separate from the sponsored landing-page data flow.</a:t>
             </a:r>
             <a:endParaRPr lang="en-US" dirty="0"/>
           </a:p>
@@ -947,7 +947,7 @@
           <a:p>
             <a:r>
               <a:rPr lang="en-US" dirty="0"/>
-              <a:t>Close with the asks: audience inputs (the ~50 organisations, the 10–12 priority names, ICP and sector priority, a named outreach owner), landing-page inputs before launch, and programme inputs. Then the two contractual dates: 18 September (brand assets, speaker name and title, initial session outline, company profile) and 30 October (final session materials, pass nominations). The Breakfast (being scoped with Caroline) and the Gala Dinner are separate paid opportunities and sit outside the £11,825 total — introduce them as natural extensions, not an upsell. End on the closing statement: we are not metering goodwill; substantial bespoke projects get scoped separately and transparently.</a:t>
+              <a:t>Close with the asks: audience inputs (the ~50 organisations, the 10–12 priority names, ICP and sector priority, a named outreach owner), landing-page inputs before launch, and programme inputs. Then the two contractual dates: 18 September (brand assets, speaker name and title, initial session outline, company profile) and 30 October (final session materials, pass nominations). The Breakfast (being scoped with Caroline) and the Gala Dinner are separate paid opportunities and sit outside the £11,825 total — as separately sponsored activations they sit above the annual partnership baseline and increase the total opportunity set. Introduce them as natural extensions, not an upsell. End on the closing statement: we are not metering goodwill; substantial bespoke projects get scoped separately and transparently.</a:t>
             </a:r>
             <a:endParaRPr lang="en-US" dirty="0"/>
           </a:p>
@@ -2842,8 +2842,8 @@
         </p:nvSpPr>
         <p:spPr>
           <a:xfrm>
-            <a:off x="7635240" y="1975104"/>
-            <a:ext cx="3733495" cy="868680"/>
+            <a:off x="7635240" y="1956816"/>
+            <a:ext cx="3733495" cy="1005840"/>
           </a:xfrm>
           <a:prstGeom prst="rect">
             <a:avLst/>
@@ -2862,7 +2862,7 @@
               <a:buNone/>
             </a:pPr>
             <a:r>
-              <a:rPr lang="en-US" sz="1250" b="1" dirty="0">
+              <a:rPr lang="en-US" sz="1150" b="1" dirty="0">
                 <a:solidFill>
                   <a:srgbClr val="121F35"/>
                 </a:solidFill>
@@ -2870,9 +2870,9 @@
                 <a:ea typeface="Calibri" pitchFamily="34" charset="-122"/>
                 <a:cs typeface="Calibri" pitchFamily="34" charset="-120"/>
               </a:rPr>
-              <a:t>Minimum 12 meaningful partnership activations across the membership year — excluding the London activation.</a:t>
-            </a:r>
-            <a:endParaRPr lang="en-US" sz="1250" dirty="0"/>
+              <a:t>Minimum 12 meaningful partnership activations across the membership year, with the London Forum expected to deliver a concentrated block of 6–9 within that commitment.</a:t>
+            </a:r>
+            <a:endParaRPr lang="en-US" sz="1150" dirty="0"/>
           </a:p>
         </p:txBody>
       </p:sp>
@@ -2884,8 +2884,8 @@
         </p:nvSpPr>
         <p:spPr>
           <a:xfrm>
-            <a:off x="6583680" y="2980944"/>
-            <a:ext cx="4785055" cy="1691640"/>
+            <a:off x="6583680" y="3090672"/>
+            <a:ext cx="4785055" cy="1664208"/>
           </a:xfrm>
           <a:prstGeom prst="rect">
             <a:avLst/>
@@ -5486,8 +5486,8 @@
         </p:nvSpPr>
         <p:spPr>
           <a:xfrm>
-            <a:off x="8183880" y="1792224"/>
-            <a:ext cx="3184855" cy="868680"/>
+            <a:off x="8183880" y="1737360"/>
+            <a:ext cx="3184855" cy="987552"/>
           </a:xfrm>
           <a:prstGeom prst="rect">
             <a:avLst/>
@@ -5506,7 +5506,7 @@
               <a:buNone/>
             </a:pPr>
             <a:r>
-              <a:rPr lang="en-US" sz="1250" b="1" dirty="0">
+              <a:rPr lang="en-US" sz="1150" b="1" dirty="0">
                 <a:solidFill>
                   <a:srgbClr val="121F35"/>
                 </a:solidFill>
@@ -5514,9 +5514,9 @@
                 <a:ea typeface="Calibri" pitchFamily="34" charset="-122"/>
                 <a:cs typeface="Calibri" pitchFamily="34" charset="-120"/>
               </a:rPr>
-              <a:t>facilitated London activations — on top of the wider 12-month partnership commitment</a:t>
-            </a:r>
-            <a:endParaRPr lang="en-US" sz="1250" dirty="0"/>
+              <a:t>facilitated London activations — a concentrated London block within the annual partnership commitment</a:t>
+            </a:r>
+            <a:endParaRPr lang="en-US" sz="1150" dirty="0"/>
           </a:p>
         </p:txBody>
       </p:sp>
@@ -5713,7 +5713,7 @@
                 <a:ea typeface="Calibri" pitchFamily="34" charset="-122"/>
                 <a:cs typeface="Calibri" pitchFamily="34" charset="-120"/>
               </a:rPr>
-              <a:t>The 6–9 London activations are additional to the minimum 12 meaningful partnership activations across the wider membership term. London does not consume the annual partnership commitment.</a:t>
+              <a:t>The 6–9 London activations may count toward the minimum 12 meaningful partnership activations across the membership year. Separately sponsored activations, such as Breakfast or Gala, increase the total opportunity set.</a:t>
             </a:r>
             <a:endParaRPr lang="en-US" sz="1050" dirty="0"/>
           </a:p>
@@ -6627,7 +6627,7 @@
               <a:buNone/>
             </a:pPr>
             <a:r>
-              <a:rPr lang="en-US" sz="1000" i="1" dirty="0">
+              <a:rPr lang="en-US" sz="950" i="1" dirty="0">
                 <a:solidFill>
                   <a:srgbClr val="55637A"/>
                 </a:solidFill>
@@ -6635,7 +6635,7 @@
                 <a:ea typeface="Calibri" pitchFamily="34" charset="-122"/>
                 <a:cs typeface="Calibri" pitchFamily="34" charset="-120"/>
               </a:rPr>
-              <a:t>   Separate paid opportunities — not included in the £11,825 value total.</a:t>
+              <a:t>   Separate paid opportunities — not included in the £11,825 value total. Separately sponsored activations sit above the annual partnership baseline and increase the total opportunity set.</a:t>
             </a:r>
             <a:endParaRPr lang="en-US" sz="1050" dirty="0"/>
           </a:p>

</xml_diff>